<commit_message>
fix: update new templates
</commit_message>
<xml_diff>
--- a/ai_core/templates/template_cong_ty_moi.pptx
+++ b/ai_core/templates/template_cong_ty_moi.pptx
@@ -107,6 +107,11 @@
       </a:defRPr>
     </a:lvl9pPr>
   </p:defaultTextStyle>
+  <p:extLst>
+    <p:ext uri="{EFAFB233-063F-42B5-8137-9DF3F51BA10A}">
+      <p15:sldGuideLst xmlns:p15="http://schemas.microsoft.com/office/powerpoint/2012/main"/>
+    </p:ext>
+  </p:extLst>
 </p:presentation>
 </file>
 
@@ -192,7 +197,7 @@
           <a:p>
             <a:fld id="{C378F526-780F-8447-AAF5-3470D79E01B4}" type="datetimeFigureOut">
               <a:rPr lang="en-VN" smtClean="0"/>
-              <a:t>11/6/26</a:t>
+              <a:t>28/6/26</a:t>
             </a:fld>
             <a:endParaRPr lang="en-VN"/>
           </a:p>
@@ -609,7 +614,7 @@
           <a:p>
             <a:fld id="{5D551AC3-8FF7-0642-B3DD-86B539C6AF55}" type="datetimeFigureOut">
               <a:rPr lang="en-VN" smtClean="0"/>
-              <a:t>11/6/26</a:t>
+              <a:t>28/6/26</a:t>
             </a:fld>
             <a:endParaRPr lang="en-VN" dirty="0"/>
           </a:p>
@@ -839,7 +844,7 @@
           <a:p>
             <a:fld id="{5D551AC3-8FF7-0642-B3DD-86B539C6AF55}" type="datetimeFigureOut">
               <a:rPr lang="en-VN" smtClean="0"/>
-              <a:t>11/6/26</a:t>
+              <a:t>28/6/26</a:t>
             </a:fld>
             <a:endParaRPr lang="en-VN"/>
           </a:p>
@@ -1049,7 +1054,7 @@
           <a:p>
             <a:fld id="{5D551AC3-8FF7-0642-B3DD-86B539C6AF55}" type="datetimeFigureOut">
               <a:rPr lang="en-VN" smtClean="0"/>
-              <a:t>11/6/26</a:t>
+              <a:t>28/6/26</a:t>
             </a:fld>
             <a:endParaRPr lang="en-VN"/>
           </a:p>
@@ -1259,7 +1264,7 @@
           <a:p>
             <a:fld id="{5D551AC3-8FF7-0642-B3DD-86B539C6AF55}" type="datetimeFigureOut">
               <a:rPr lang="en-VN" smtClean="0"/>
-              <a:t>11/6/26</a:t>
+              <a:t>28/6/26</a:t>
             </a:fld>
             <a:endParaRPr lang="en-VN"/>
           </a:p>
@@ -1598,7 +1603,7 @@
           <a:p>
             <a:fld id="{5D551AC3-8FF7-0642-B3DD-86B539C6AF55}" type="datetimeFigureOut">
               <a:rPr lang="en-VN" smtClean="0"/>
-              <a:t>11/6/26</a:t>
+              <a:t>28/6/26</a:t>
             </a:fld>
             <a:endParaRPr lang="en-VN"/>
           </a:p>
@@ -1866,7 +1871,7 @@
           <a:p>
             <a:fld id="{5D551AC3-8FF7-0642-B3DD-86B539C6AF55}" type="datetimeFigureOut">
               <a:rPr lang="en-VN" smtClean="0"/>
-              <a:t>11/6/26</a:t>
+              <a:t>28/6/26</a:t>
             </a:fld>
             <a:endParaRPr lang="en-VN"/>
           </a:p>
@@ -2281,7 +2286,7 @@
           <a:p>
             <a:fld id="{5D551AC3-8FF7-0642-B3DD-86B539C6AF55}" type="datetimeFigureOut">
               <a:rPr lang="en-VN" smtClean="0"/>
-              <a:t>11/6/26</a:t>
+              <a:t>28/6/26</a:t>
             </a:fld>
             <a:endParaRPr lang="en-VN"/>
           </a:p>
@@ -2423,7 +2428,7 @@
           <a:p>
             <a:fld id="{5D551AC3-8FF7-0642-B3DD-86B539C6AF55}" type="datetimeFigureOut">
               <a:rPr lang="en-VN" smtClean="0"/>
-              <a:t>11/6/26</a:t>
+              <a:t>28/6/26</a:t>
             </a:fld>
             <a:endParaRPr lang="en-VN"/>
           </a:p>
@@ -2536,7 +2541,7 @@
           <a:p>
             <a:fld id="{5D551AC3-8FF7-0642-B3DD-86B539C6AF55}" type="datetimeFigureOut">
               <a:rPr lang="en-VN" smtClean="0"/>
-              <a:t>11/6/26</a:t>
+              <a:t>28/6/26</a:t>
             </a:fld>
             <a:endParaRPr lang="en-VN"/>
           </a:p>
@@ -2849,7 +2854,7 @@
           <a:p>
             <a:fld id="{5D551AC3-8FF7-0642-B3DD-86B539C6AF55}" type="datetimeFigureOut">
               <a:rPr lang="en-VN" smtClean="0"/>
-              <a:t>11/6/26</a:t>
+              <a:t>28/6/26</a:t>
             </a:fld>
             <a:endParaRPr lang="en-VN"/>
           </a:p>
@@ -3138,7 +3143,7 @@
           <a:p>
             <a:fld id="{5D551AC3-8FF7-0642-B3DD-86B539C6AF55}" type="datetimeFigureOut">
               <a:rPr lang="en-VN" smtClean="0"/>
-              <a:t>11/6/26</a:t>
+              <a:t>28/6/26</a:t>
             </a:fld>
             <a:endParaRPr lang="en-VN"/>
           </a:p>
@@ -3381,7 +3386,7 @@
           <a:p>
             <a:fld id="{5D551AC3-8FF7-0642-B3DD-86B539C6AF55}" type="datetimeFigureOut">
               <a:rPr lang="en-VN" smtClean="0"/>
-              <a:t>11/6/26</a:t>
+              <a:t>28/6/26</a:t>
             </a:fld>
             <a:endParaRPr lang="en-VN"/>
           </a:p>
@@ -3828,58 +3833,6 @@
           <a:chExt cx="0" cy="0"/>
         </a:xfrm>
       </p:grpSpPr>
-      <p:sp>
-        <p:nvSpPr>
-          <p:cNvPr id="2" name="Title 1">
-            <a:extLst>
-              <a:ext uri="{FF2B5EF4-FFF2-40B4-BE49-F238E27FC236}">
-                <a16:creationId xmlns:a16="http://schemas.microsoft.com/office/drawing/2014/main" id="{7CFAB77C-1028-6CE6-0A24-31EE63B685CF}"/>
-              </a:ext>
-            </a:extLst>
-          </p:cNvPr>
-          <p:cNvSpPr>
-            <a:spLocks noGrp="1"/>
-          </p:cNvSpPr>
-          <p:nvPr>
-            <p:ph type="ctrTitle"/>
-          </p:nvPr>
-        </p:nvSpPr>
-        <p:spPr/>
-        <p:txBody>
-          <a:bodyPr>
-            <a:normAutofit fontScale="90000"/>
-          </a:bodyPr>
-          <a:lstStyle/>
-          <a:p>
-            <a:endParaRPr lang="en-VN" dirty="0"/>
-          </a:p>
-        </p:txBody>
-      </p:sp>
-      <p:sp>
-        <p:nvSpPr>
-          <p:cNvPr id="3" name="Subtitle 2">
-            <a:extLst>
-              <a:ext uri="{FF2B5EF4-FFF2-40B4-BE49-F238E27FC236}">
-                <a16:creationId xmlns:a16="http://schemas.microsoft.com/office/drawing/2014/main" id="{55CA5F64-76C8-A408-2A91-2E98E262D84B}"/>
-              </a:ext>
-            </a:extLst>
-          </p:cNvPr>
-          <p:cNvSpPr>
-            <a:spLocks noGrp="1"/>
-          </p:cNvSpPr>
-          <p:nvPr>
-            <p:ph type="subTitle" idx="1"/>
-          </p:nvPr>
-        </p:nvSpPr>
-        <p:spPr/>
-        <p:txBody>
-          <a:bodyPr/>
-          <a:lstStyle/>
-          <a:p>
-            <a:endParaRPr lang="en-VN" dirty="0"/>
-          </a:p>
-        </p:txBody>
-      </p:sp>
     </p:spTree>
     <p:extLst>
       <p:ext uri="{BB962C8B-B14F-4D97-AF65-F5344CB8AC3E}">

</xml_diff>